<commit_message>
add TCN for temporal module
</commit_message>
<xml_diff>
--- a/主图.pptx
+++ b/主图.pptx
@@ -6,6 +6,7 @@
   </p:sldMasterIdLst>
   <p:sldIdLst>
     <p:sldId id="257" r:id="rId2"/>
+    <p:sldId id="258" r:id="rId3"/>
   </p:sldIdLst>
   <p:sldSz cx="12192000" cy="6858000"/>
   <p:notesSz cx="6858000" cy="9144000"/>
@@ -259,7 +260,7 @@
           <a:p>
             <a:fld id="{8CC5C8A1-0F93-4DB0-B1B4-92CB69981D72}" type="datetimeFigureOut">
               <a:rPr lang="zh-CN" altLang="en-US" smtClean="0"/>
-              <a:t>2025/8/11</a:t>
+              <a:t>2025/12/28</a:t>
             </a:fld>
             <a:endParaRPr lang="zh-CN" altLang="en-US"/>
           </a:p>
@@ -457,7 +458,7 @@
           <a:p>
             <a:fld id="{8CC5C8A1-0F93-4DB0-B1B4-92CB69981D72}" type="datetimeFigureOut">
               <a:rPr lang="zh-CN" altLang="en-US" smtClean="0"/>
-              <a:t>2025/8/11</a:t>
+              <a:t>2025/12/28</a:t>
             </a:fld>
             <a:endParaRPr lang="zh-CN" altLang="en-US"/>
           </a:p>
@@ -665,7 +666,7 @@
           <a:p>
             <a:fld id="{8CC5C8A1-0F93-4DB0-B1B4-92CB69981D72}" type="datetimeFigureOut">
               <a:rPr lang="zh-CN" altLang="en-US" smtClean="0"/>
-              <a:t>2025/8/11</a:t>
+              <a:t>2025/12/28</a:t>
             </a:fld>
             <a:endParaRPr lang="zh-CN" altLang="en-US"/>
           </a:p>
@@ -863,7 +864,7 @@
           <a:p>
             <a:fld id="{8CC5C8A1-0F93-4DB0-B1B4-92CB69981D72}" type="datetimeFigureOut">
               <a:rPr lang="zh-CN" altLang="en-US" smtClean="0"/>
-              <a:t>2025/8/11</a:t>
+              <a:t>2025/12/28</a:t>
             </a:fld>
             <a:endParaRPr lang="zh-CN" altLang="en-US"/>
           </a:p>
@@ -1138,7 +1139,7 @@
           <a:p>
             <a:fld id="{8CC5C8A1-0F93-4DB0-B1B4-92CB69981D72}" type="datetimeFigureOut">
               <a:rPr lang="zh-CN" altLang="en-US" smtClean="0"/>
-              <a:t>2025/8/11</a:t>
+              <a:t>2025/12/28</a:t>
             </a:fld>
             <a:endParaRPr lang="zh-CN" altLang="en-US"/>
           </a:p>
@@ -1403,7 +1404,7 @@
           <a:p>
             <a:fld id="{8CC5C8A1-0F93-4DB0-B1B4-92CB69981D72}" type="datetimeFigureOut">
               <a:rPr lang="zh-CN" altLang="en-US" smtClean="0"/>
-              <a:t>2025/8/11</a:t>
+              <a:t>2025/12/28</a:t>
             </a:fld>
             <a:endParaRPr lang="zh-CN" altLang="en-US"/>
           </a:p>
@@ -1815,7 +1816,7 @@
           <a:p>
             <a:fld id="{8CC5C8A1-0F93-4DB0-B1B4-92CB69981D72}" type="datetimeFigureOut">
               <a:rPr lang="zh-CN" altLang="en-US" smtClean="0"/>
-              <a:t>2025/8/11</a:t>
+              <a:t>2025/12/28</a:t>
             </a:fld>
             <a:endParaRPr lang="zh-CN" altLang="en-US"/>
           </a:p>
@@ -1956,7 +1957,7 @@
           <a:p>
             <a:fld id="{8CC5C8A1-0F93-4DB0-B1B4-92CB69981D72}" type="datetimeFigureOut">
               <a:rPr lang="zh-CN" altLang="en-US" smtClean="0"/>
-              <a:t>2025/8/11</a:t>
+              <a:t>2025/12/28</a:t>
             </a:fld>
             <a:endParaRPr lang="zh-CN" altLang="en-US"/>
           </a:p>
@@ -2069,7 +2070,7 @@
           <a:p>
             <a:fld id="{8CC5C8A1-0F93-4DB0-B1B4-92CB69981D72}" type="datetimeFigureOut">
               <a:rPr lang="zh-CN" altLang="en-US" smtClean="0"/>
-              <a:t>2025/8/11</a:t>
+              <a:t>2025/12/28</a:t>
             </a:fld>
             <a:endParaRPr lang="zh-CN" altLang="en-US"/>
           </a:p>
@@ -2380,7 +2381,7 @@
           <a:p>
             <a:fld id="{8CC5C8A1-0F93-4DB0-B1B4-92CB69981D72}" type="datetimeFigureOut">
               <a:rPr lang="zh-CN" altLang="en-US" smtClean="0"/>
-              <a:t>2025/8/11</a:t>
+              <a:t>2025/12/28</a:t>
             </a:fld>
             <a:endParaRPr lang="zh-CN" altLang="en-US"/>
           </a:p>
@@ -2668,7 +2669,7 @@
           <a:p>
             <a:fld id="{8CC5C8A1-0F93-4DB0-B1B4-92CB69981D72}" type="datetimeFigureOut">
               <a:rPr lang="zh-CN" altLang="en-US" smtClean="0"/>
-              <a:t>2025/8/11</a:t>
+              <a:t>2025/12/28</a:t>
             </a:fld>
             <a:endParaRPr lang="zh-CN" altLang="en-US"/>
           </a:p>
@@ -2909,7 +2910,7 @@
           <a:p>
             <a:fld id="{8CC5C8A1-0F93-4DB0-B1B4-92CB69981D72}" type="datetimeFigureOut">
               <a:rPr lang="zh-CN" altLang="en-US" smtClean="0"/>
-              <a:t>2025/8/11</a:t>
+              <a:t>2025/12/28</a:t>
             </a:fld>
             <a:endParaRPr lang="zh-CN" altLang="en-US"/>
           </a:p>
@@ -5608,6 +5609,1651 @@
     <p:extLst>
       <p:ext uri="{BB962C8B-B14F-4D97-AF65-F5344CB8AC3E}">
         <p14:creationId xmlns:p14="http://schemas.microsoft.com/office/powerpoint/2010/main" val="2972805586"/>
+      </p:ext>
+    </p:extLst>
+  </p:cSld>
+  <p:clrMapOvr>
+    <a:masterClrMapping/>
+  </p:clrMapOvr>
+</p:sld>
+</file>
+
+<file path=ppt/slides/slide2.xml><?xml version="1.0" encoding="utf-8"?>
+<p:sld xmlns:a="http://schemas.openxmlformats.org/drawingml/2006/main" xmlns:r="http://schemas.openxmlformats.org/officeDocument/2006/relationships" xmlns:p="http://schemas.openxmlformats.org/presentationml/2006/main">
+  <p:cSld>
+    <p:spTree>
+      <p:nvGrpSpPr>
+        <p:cNvPr id="1" name="">
+          <a:extLst>
+            <a:ext uri="{FF2B5EF4-FFF2-40B4-BE49-F238E27FC236}">
+              <a16:creationId xmlns:a16="http://schemas.microsoft.com/office/drawing/2014/main" id="{71B775EF-9DC4-9F44-A5F1-61EE954D0BF7}"/>
+            </a:ext>
+          </a:extLst>
+        </p:cNvPr>
+        <p:cNvGrpSpPr/>
+        <p:nvPr/>
+      </p:nvGrpSpPr>
+      <p:grpSpPr>
+        <a:xfrm>
+          <a:off x="0" y="0"/>
+          <a:ext cx="0" cy="0"/>
+          <a:chOff x="0" y="0"/>
+          <a:chExt cx="0" cy="0"/>
+        </a:xfrm>
+      </p:grpSpPr>
+      <p:sp>
+        <p:nvSpPr>
+          <p:cNvPr id="6" name="矩形: 圆角 5">
+            <a:extLst>
+              <a:ext uri="{FF2B5EF4-FFF2-40B4-BE49-F238E27FC236}">
+                <a16:creationId xmlns:a16="http://schemas.microsoft.com/office/drawing/2014/main" id="{94BA8E38-F61D-0F9C-61F7-DEEE834DC1E6}"/>
+              </a:ext>
+            </a:extLst>
+          </p:cNvPr>
+          <p:cNvSpPr/>
+          <p:nvPr/>
+        </p:nvSpPr>
+        <p:spPr>
+          <a:xfrm>
+            <a:off x="3717783" y="2207031"/>
+            <a:ext cx="3222253" cy="1140059"/>
+          </a:xfrm>
+          <a:prstGeom prst="roundRect">
+            <a:avLst>
+              <a:gd name="adj" fmla="val 5725"/>
+            </a:avLst>
+          </a:prstGeom>
+          <a:noFill/>
+          <a:ln w="19050">
+            <a:prstDash val="solid"/>
+          </a:ln>
+        </p:spPr>
+        <p:style>
+          <a:lnRef idx="2">
+            <a:schemeClr val="accent1">
+              <a:shade val="15000"/>
+            </a:schemeClr>
+          </a:lnRef>
+          <a:fillRef idx="1">
+            <a:schemeClr val="accent1"/>
+          </a:fillRef>
+          <a:effectRef idx="0">
+            <a:schemeClr val="accent1"/>
+          </a:effectRef>
+          <a:fontRef idx="minor">
+            <a:schemeClr val="lt1"/>
+          </a:fontRef>
+        </p:style>
+        <p:txBody>
+          <a:bodyPr rtlCol="0" anchor="ctr"/>
+          <a:lstStyle/>
+          <a:p>
+            <a:pPr algn="ctr"/>
+            <a:endParaRPr lang="zh-CN" altLang="en-US"/>
+          </a:p>
+        </p:txBody>
+      </p:sp>
+      <p:sp>
+        <p:nvSpPr>
+          <p:cNvPr id="7" name="文本框 6">
+            <a:extLst>
+              <a:ext uri="{FF2B5EF4-FFF2-40B4-BE49-F238E27FC236}">
+                <a16:creationId xmlns:a16="http://schemas.microsoft.com/office/drawing/2014/main" id="{8A980C1A-9D4E-AE85-F856-975EFA3D5277}"/>
+              </a:ext>
+            </a:extLst>
+          </p:cNvPr>
+          <p:cNvSpPr txBox="1"/>
+          <p:nvPr/>
+        </p:nvSpPr>
+        <p:spPr>
+          <a:xfrm>
+            <a:off x="4798325" y="2168319"/>
+            <a:ext cx="1061168" cy="338554"/>
+          </a:xfrm>
+          <a:prstGeom prst="rect">
+            <a:avLst/>
+          </a:prstGeom>
+          <a:noFill/>
+        </p:spPr>
+        <p:txBody>
+          <a:bodyPr wrap="square" rtlCol="0">
+            <a:spAutoFit/>
+          </a:bodyPr>
+          <a:lstStyle/>
+          <a:p>
+            <a:r>
+              <a:rPr lang="zh-CN" altLang="en-US" sz="1600" dirty="0"/>
+              <a:t>策略网络</a:t>
+            </a:r>
+          </a:p>
+        </p:txBody>
+      </p:sp>
+      <p:sp>
+        <p:nvSpPr>
+          <p:cNvPr id="10" name="文本框 9">
+            <a:extLst>
+              <a:ext uri="{FF2B5EF4-FFF2-40B4-BE49-F238E27FC236}">
+                <a16:creationId xmlns:a16="http://schemas.microsoft.com/office/drawing/2014/main" id="{DBFC73A9-53FC-C54B-C90A-7F751216BFE4}"/>
+              </a:ext>
+            </a:extLst>
+          </p:cNvPr>
+          <p:cNvSpPr txBox="1"/>
+          <p:nvPr/>
+        </p:nvSpPr>
+        <p:spPr>
+          <a:xfrm>
+            <a:off x="3620367" y="2429273"/>
+            <a:ext cx="1161626" cy="738664"/>
+          </a:xfrm>
+          <a:prstGeom prst="rect">
+            <a:avLst/>
+          </a:prstGeom>
+          <a:noFill/>
+        </p:spPr>
+        <p:txBody>
+          <a:bodyPr wrap="square" rtlCol="0">
+            <a:spAutoFit/>
+          </a:bodyPr>
+          <a:lstStyle/>
+          <a:p>
+            <a:pPr algn="ctr"/>
+            <a:r>
+              <a:rPr lang="zh-CN" altLang="en-US" sz="1400" dirty="0"/>
+              <a:t>视觉</a:t>
+            </a:r>
+            <a:r>
+              <a:rPr lang="en-US" altLang="zh-CN" sz="1400" dirty="0"/>
+              <a:t>Transformer</a:t>
+            </a:r>
+            <a:r>
+              <a:rPr lang="zh-CN" altLang="en-US" sz="1400" dirty="0"/>
+              <a:t>网络</a:t>
+            </a:r>
+          </a:p>
+        </p:txBody>
+      </p:sp>
+      <p:sp>
+        <p:nvSpPr>
+          <p:cNvPr id="11" name="文本框 10">
+            <a:extLst>
+              <a:ext uri="{FF2B5EF4-FFF2-40B4-BE49-F238E27FC236}">
+                <a16:creationId xmlns:a16="http://schemas.microsoft.com/office/drawing/2014/main" id="{6FA365DB-ECC9-2DA2-230F-97C87F8A5516}"/>
+              </a:ext>
+            </a:extLst>
+          </p:cNvPr>
+          <p:cNvSpPr txBox="1"/>
+          <p:nvPr/>
+        </p:nvSpPr>
+        <p:spPr>
+          <a:xfrm>
+            <a:off x="4985869" y="2429273"/>
+            <a:ext cx="1132182" cy="738664"/>
+          </a:xfrm>
+          <a:prstGeom prst="rect">
+            <a:avLst/>
+          </a:prstGeom>
+          <a:noFill/>
+        </p:spPr>
+        <p:txBody>
+          <a:bodyPr wrap="square" rtlCol="0">
+            <a:spAutoFit/>
+          </a:bodyPr>
+          <a:lstStyle/>
+          <a:p>
+            <a:pPr algn="ctr"/>
+            <a:r>
+              <a:rPr lang="zh-CN" altLang="en-US" sz="1400" dirty="0"/>
+              <a:t>时序</a:t>
+            </a:r>
+            <a:r>
+              <a:rPr lang="en-US" altLang="zh-CN" sz="1400" dirty="0"/>
+              <a:t>Transformer</a:t>
+            </a:r>
+            <a:r>
+              <a:rPr lang="zh-CN" altLang="en-US" sz="1400" dirty="0"/>
+              <a:t>网络</a:t>
+            </a:r>
+          </a:p>
+        </p:txBody>
+      </p:sp>
+      <p:sp>
+        <p:nvSpPr>
+          <p:cNvPr id="12" name="文本框 11">
+            <a:extLst>
+              <a:ext uri="{FF2B5EF4-FFF2-40B4-BE49-F238E27FC236}">
+                <a16:creationId xmlns:a16="http://schemas.microsoft.com/office/drawing/2014/main" id="{C9BB45E5-B655-71F8-851B-979C0EC2655E}"/>
+              </a:ext>
+            </a:extLst>
+          </p:cNvPr>
+          <p:cNvSpPr txBox="1"/>
+          <p:nvPr/>
+        </p:nvSpPr>
+        <p:spPr>
+          <a:xfrm>
+            <a:off x="6170862" y="2536995"/>
+            <a:ext cx="864327" cy="523220"/>
+          </a:xfrm>
+          <a:prstGeom prst="rect">
+            <a:avLst/>
+          </a:prstGeom>
+          <a:noFill/>
+        </p:spPr>
+        <p:txBody>
+          <a:bodyPr wrap="square" rtlCol="0">
+            <a:spAutoFit/>
+          </a:bodyPr>
+          <a:lstStyle/>
+          <a:p>
+            <a:pPr algn="ctr"/>
+            <a:r>
+              <a:rPr lang="zh-CN" altLang="en-US" sz="1400" dirty="0"/>
+              <a:t>全连接网络</a:t>
+            </a:r>
+          </a:p>
+        </p:txBody>
+      </p:sp>
+      <p:cxnSp>
+        <p:nvCxnSpPr>
+          <p:cNvPr id="8" name="直接箭头连接符 7">
+            <a:extLst>
+              <a:ext uri="{FF2B5EF4-FFF2-40B4-BE49-F238E27FC236}">
+                <a16:creationId xmlns:a16="http://schemas.microsoft.com/office/drawing/2014/main" id="{B350D459-048A-1E09-0018-E292168BDB29}"/>
+              </a:ext>
+            </a:extLst>
+          </p:cNvPr>
+          <p:cNvCxnSpPr>
+            <a:cxnSpLocks/>
+            <a:endCxn id="11" idx="1"/>
+          </p:cNvCxnSpPr>
+          <p:nvPr/>
+        </p:nvCxnSpPr>
+        <p:spPr>
+          <a:xfrm>
+            <a:off x="4719360" y="2798605"/>
+            <a:ext cx="266509" cy="0"/>
+          </a:xfrm>
+          <a:prstGeom prst="straightConnector1">
+            <a:avLst/>
+          </a:prstGeom>
+          <a:ln>
+            <a:solidFill>
+              <a:schemeClr val="tx1"/>
+            </a:solidFill>
+            <a:tailEnd type="triangle"/>
+          </a:ln>
+        </p:spPr>
+        <p:style>
+          <a:lnRef idx="2">
+            <a:schemeClr val="accent1"/>
+          </a:lnRef>
+          <a:fillRef idx="0">
+            <a:schemeClr val="accent1"/>
+          </a:fillRef>
+          <a:effectRef idx="1">
+            <a:schemeClr val="accent1"/>
+          </a:effectRef>
+          <a:fontRef idx="minor">
+            <a:schemeClr val="tx1"/>
+          </a:fontRef>
+        </p:style>
+      </p:cxnSp>
+      <p:sp>
+        <p:nvSpPr>
+          <p:cNvPr id="19" name="矩形: 圆角 18">
+            <a:extLst>
+              <a:ext uri="{FF2B5EF4-FFF2-40B4-BE49-F238E27FC236}">
+                <a16:creationId xmlns:a16="http://schemas.microsoft.com/office/drawing/2014/main" id="{C5CBE168-842B-71D1-A7CE-DEBAC88C5866}"/>
+              </a:ext>
+            </a:extLst>
+          </p:cNvPr>
+          <p:cNvSpPr/>
+          <p:nvPr/>
+        </p:nvSpPr>
+        <p:spPr>
+          <a:xfrm>
+            <a:off x="1333500" y="1243784"/>
+            <a:ext cx="2138694" cy="659172"/>
+          </a:xfrm>
+          <a:prstGeom prst="roundRect">
+            <a:avLst>
+              <a:gd name="adj" fmla="val 14973"/>
+            </a:avLst>
+          </a:prstGeom>
+          <a:noFill/>
+          <a:ln w="19050">
+            <a:prstDash val="solid"/>
+          </a:ln>
+        </p:spPr>
+        <p:style>
+          <a:lnRef idx="2">
+            <a:schemeClr val="accent1">
+              <a:shade val="15000"/>
+            </a:schemeClr>
+          </a:lnRef>
+          <a:fillRef idx="1">
+            <a:schemeClr val="accent1"/>
+          </a:fillRef>
+          <a:effectRef idx="0">
+            <a:schemeClr val="accent1"/>
+          </a:effectRef>
+          <a:fontRef idx="minor">
+            <a:schemeClr val="lt1"/>
+          </a:fontRef>
+        </p:style>
+        <p:txBody>
+          <a:bodyPr rtlCol="0" anchor="ctr"/>
+          <a:lstStyle/>
+          <a:p>
+            <a:pPr algn="ctr"/>
+            <a:r>
+              <a:rPr lang="zh-CN" altLang="en-US" dirty="0">
+                <a:solidFill>
+                  <a:schemeClr val="tx1"/>
+                </a:solidFill>
+              </a:rPr>
+              <a:t>环境</a:t>
+            </a:r>
+          </a:p>
+        </p:txBody>
+      </p:sp>
+      <p:cxnSp>
+        <p:nvCxnSpPr>
+          <p:cNvPr id="21" name="直接箭头连接符 20">
+            <a:extLst>
+              <a:ext uri="{FF2B5EF4-FFF2-40B4-BE49-F238E27FC236}">
+                <a16:creationId xmlns:a16="http://schemas.microsoft.com/office/drawing/2014/main" id="{6E6136F5-5D52-CF57-CE29-741A5CE7D3FD}"/>
+              </a:ext>
+            </a:extLst>
+          </p:cNvPr>
+          <p:cNvCxnSpPr>
+            <a:cxnSpLocks/>
+            <a:stCxn id="19" idx="3"/>
+            <a:endCxn id="25" idx="1"/>
+          </p:cNvCxnSpPr>
+          <p:nvPr/>
+        </p:nvCxnSpPr>
+        <p:spPr>
+          <a:xfrm>
+            <a:off x="3472194" y="1573370"/>
+            <a:ext cx="935956" cy="4508"/>
+          </a:xfrm>
+          <a:prstGeom prst="straightConnector1">
+            <a:avLst/>
+          </a:prstGeom>
+          <a:ln>
+            <a:solidFill>
+              <a:schemeClr val="tx1"/>
+            </a:solidFill>
+            <a:tailEnd type="triangle"/>
+          </a:ln>
+        </p:spPr>
+        <p:style>
+          <a:lnRef idx="2">
+            <a:schemeClr val="accent1"/>
+          </a:lnRef>
+          <a:fillRef idx="0">
+            <a:schemeClr val="accent1"/>
+          </a:fillRef>
+          <a:effectRef idx="1">
+            <a:schemeClr val="accent1"/>
+          </a:effectRef>
+          <a:fontRef idx="minor">
+            <a:schemeClr val="tx1"/>
+          </a:fontRef>
+        </p:style>
+      </p:cxnSp>
+      <p:sp>
+        <p:nvSpPr>
+          <p:cNvPr id="23" name="文本框 22">
+            <a:extLst>
+              <a:ext uri="{FF2B5EF4-FFF2-40B4-BE49-F238E27FC236}">
+                <a16:creationId xmlns:a16="http://schemas.microsoft.com/office/drawing/2014/main" id="{DFB5C801-933B-7E91-E8BF-094F45814F5E}"/>
+              </a:ext>
+            </a:extLst>
+          </p:cNvPr>
+          <p:cNvSpPr txBox="1"/>
+          <p:nvPr/>
+        </p:nvSpPr>
+        <p:spPr>
+          <a:xfrm>
+            <a:off x="2492767" y="2339930"/>
+            <a:ext cx="632764" cy="461665"/>
+          </a:xfrm>
+          <a:prstGeom prst="rect">
+            <a:avLst/>
+          </a:prstGeom>
+          <a:noFill/>
+        </p:spPr>
+        <p:txBody>
+          <a:bodyPr wrap="square" rtlCol="0">
+            <a:spAutoFit/>
+          </a:bodyPr>
+          <a:lstStyle/>
+          <a:p>
+            <a:pPr algn="ctr"/>
+            <a:r>
+              <a:rPr lang="zh-CN" altLang="en-US" sz="1200" dirty="0"/>
+              <a:t>图像张量</a:t>
+            </a:r>
+          </a:p>
+        </p:txBody>
+      </p:sp>
+      <p:sp>
+        <p:nvSpPr>
+          <p:cNvPr id="25" name="矩形: 圆角 24">
+            <a:extLst>
+              <a:ext uri="{FF2B5EF4-FFF2-40B4-BE49-F238E27FC236}">
+                <a16:creationId xmlns:a16="http://schemas.microsoft.com/office/drawing/2014/main" id="{3F00E48D-FA28-DCE5-FBAE-04995050F2B5}"/>
+              </a:ext>
+            </a:extLst>
+          </p:cNvPr>
+          <p:cNvSpPr/>
+          <p:nvPr/>
+        </p:nvSpPr>
+        <p:spPr>
+          <a:xfrm>
+            <a:off x="4408150" y="1248291"/>
+            <a:ext cx="1600107" cy="659173"/>
+          </a:xfrm>
+          <a:prstGeom prst="roundRect">
+            <a:avLst>
+              <a:gd name="adj" fmla="val 11120"/>
+            </a:avLst>
+          </a:prstGeom>
+          <a:noFill/>
+          <a:ln w="19050">
+            <a:prstDash val="solid"/>
+          </a:ln>
+        </p:spPr>
+        <p:style>
+          <a:lnRef idx="2">
+            <a:schemeClr val="accent1">
+              <a:shade val="15000"/>
+            </a:schemeClr>
+          </a:lnRef>
+          <a:fillRef idx="1">
+            <a:schemeClr val="accent1"/>
+          </a:fillRef>
+          <a:effectRef idx="0">
+            <a:schemeClr val="accent1"/>
+          </a:effectRef>
+          <a:fontRef idx="minor">
+            <a:schemeClr val="lt1"/>
+          </a:fontRef>
+        </p:style>
+        <p:txBody>
+          <a:bodyPr rtlCol="0" anchor="ctr"/>
+          <a:lstStyle/>
+          <a:p>
+            <a:pPr algn="ctr"/>
+            <a:r>
+              <a:rPr lang="zh-CN" altLang="en-US" dirty="0">
+                <a:solidFill>
+                  <a:schemeClr val="tx1"/>
+                </a:solidFill>
+              </a:rPr>
+              <a:t>  评价网络</a:t>
+            </a:r>
+            <a:endParaRPr lang="en-US" altLang="zh-CN" dirty="0">
+              <a:solidFill>
+                <a:schemeClr val="tx1"/>
+              </a:solidFill>
+            </a:endParaRPr>
+          </a:p>
+          <a:p>
+            <a:pPr algn="ctr"/>
+            <a:r>
+              <a:rPr lang="zh-CN" altLang="en-US" dirty="0">
+                <a:solidFill>
+                  <a:schemeClr val="tx1"/>
+                </a:solidFill>
+              </a:rPr>
+              <a:t>（全连接网络）</a:t>
+            </a:r>
+          </a:p>
+        </p:txBody>
+      </p:sp>
+      <p:sp>
+        <p:nvSpPr>
+          <p:cNvPr id="33" name="文本框 32">
+            <a:extLst>
+              <a:ext uri="{FF2B5EF4-FFF2-40B4-BE49-F238E27FC236}">
+                <a16:creationId xmlns:a16="http://schemas.microsoft.com/office/drawing/2014/main" id="{9A056313-CCA4-2504-3D33-3FDB41EB22AA}"/>
+              </a:ext>
+            </a:extLst>
+          </p:cNvPr>
+          <p:cNvSpPr txBox="1"/>
+          <p:nvPr/>
+        </p:nvSpPr>
+        <p:spPr>
+          <a:xfrm>
+            <a:off x="3318153" y="1294335"/>
+            <a:ext cx="1244038" cy="276999"/>
+          </a:xfrm>
+          <a:prstGeom prst="rect">
+            <a:avLst/>
+          </a:prstGeom>
+          <a:noFill/>
+        </p:spPr>
+        <p:txBody>
+          <a:bodyPr wrap="square" rtlCol="0">
+            <a:spAutoFit/>
+          </a:bodyPr>
+          <a:lstStyle/>
+          <a:p>
+            <a:pPr algn="ctr"/>
+            <a:r>
+              <a:rPr lang="zh-CN" altLang="en-US" sz="1200" dirty="0"/>
+              <a:t>特权真值信息</a:t>
+            </a:r>
+          </a:p>
+        </p:txBody>
+      </p:sp>
+      <p:cxnSp>
+        <p:nvCxnSpPr>
+          <p:cNvPr id="65" name="直接箭头连接符 64">
+            <a:extLst>
+              <a:ext uri="{FF2B5EF4-FFF2-40B4-BE49-F238E27FC236}">
+                <a16:creationId xmlns:a16="http://schemas.microsoft.com/office/drawing/2014/main" id="{6A66D1E9-1C90-4121-AA94-B55AE457F424}"/>
+              </a:ext>
+            </a:extLst>
+          </p:cNvPr>
+          <p:cNvCxnSpPr>
+            <a:cxnSpLocks/>
+          </p:cNvCxnSpPr>
+          <p:nvPr/>
+        </p:nvCxnSpPr>
+        <p:spPr>
+          <a:xfrm flipV="1">
+            <a:off x="6050395" y="2796471"/>
+            <a:ext cx="261862" cy="2134"/>
+          </a:xfrm>
+          <a:prstGeom prst="straightConnector1">
+            <a:avLst/>
+          </a:prstGeom>
+          <a:ln>
+            <a:solidFill>
+              <a:schemeClr val="tx1"/>
+            </a:solidFill>
+            <a:tailEnd type="triangle"/>
+          </a:ln>
+        </p:spPr>
+        <p:style>
+          <a:lnRef idx="2">
+            <a:schemeClr val="accent1"/>
+          </a:lnRef>
+          <a:fillRef idx="0">
+            <a:schemeClr val="accent1"/>
+          </a:fillRef>
+          <a:effectRef idx="1">
+            <a:schemeClr val="accent1"/>
+          </a:effectRef>
+          <a:fontRef idx="minor">
+            <a:schemeClr val="tx1"/>
+          </a:fontRef>
+        </p:style>
+      </p:cxnSp>
+      <p:sp>
+        <p:nvSpPr>
+          <p:cNvPr id="70" name="矩形: 圆角 69">
+            <a:extLst>
+              <a:ext uri="{FF2B5EF4-FFF2-40B4-BE49-F238E27FC236}">
+                <a16:creationId xmlns:a16="http://schemas.microsoft.com/office/drawing/2014/main" id="{E0A79323-D3AA-F697-87F1-A25C8B281583}"/>
+              </a:ext>
+            </a:extLst>
+          </p:cNvPr>
+          <p:cNvSpPr/>
+          <p:nvPr/>
+        </p:nvSpPr>
+        <p:spPr>
+          <a:xfrm>
+            <a:off x="1655931" y="4038249"/>
+            <a:ext cx="1493832" cy="723900"/>
+          </a:xfrm>
+          <a:prstGeom prst="roundRect">
+            <a:avLst/>
+          </a:prstGeom>
+          <a:noFill/>
+        </p:spPr>
+        <p:style>
+          <a:lnRef idx="2">
+            <a:schemeClr val="accent1">
+              <a:shade val="15000"/>
+            </a:schemeClr>
+          </a:lnRef>
+          <a:fillRef idx="1">
+            <a:schemeClr val="accent1"/>
+          </a:fillRef>
+          <a:effectRef idx="0">
+            <a:schemeClr val="accent1"/>
+          </a:effectRef>
+          <a:fontRef idx="minor">
+            <a:schemeClr val="lt1"/>
+          </a:fontRef>
+        </p:style>
+        <p:txBody>
+          <a:bodyPr rtlCol="0" anchor="ctr"/>
+          <a:lstStyle/>
+          <a:p>
+            <a:pPr algn="ctr"/>
+            <a:r>
+              <a:rPr lang="en-US" altLang="zh-CN" dirty="0">
+                <a:solidFill>
+                  <a:schemeClr val="tx1"/>
+                </a:solidFill>
+              </a:rPr>
+              <a:t>CEM-MPPI</a:t>
+            </a:r>
+            <a:endParaRPr lang="zh-CN" altLang="en-US" dirty="0">
+              <a:solidFill>
+                <a:schemeClr val="tx1"/>
+              </a:solidFill>
+            </a:endParaRPr>
+          </a:p>
+        </p:txBody>
+      </p:sp>
+      <p:cxnSp>
+        <p:nvCxnSpPr>
+          <p:cNvPr id="71" name="直接箭头连接符 70">
+            <a:extLst>
+              <a:ext uri="{FF2B5EF4-FFF2-40B4-BE49-F238E27FC236}">
+                <a16:creationId xmlns:a16="http://schemas.microsoft.com/office/drawing/2014/main" id="{2B0144DF-9597-AD06-ACDC-EF36C86EB0B5}"/>
+              </a:ext>
+            </a:extLst>
+          </p:cNvPr>
+          <p:cNvCxnSpPr>
+            <a:cxnSpLocks/>
+            <a:stCxn id="19" idx="2"/>
+            <a:endCxn id="70" idx="0"/>
+          </p:cNvCxnSpPr>
+          <p:nvPr/>
+        </p:nvCxnSpPr>
+        <p:spPr>
+          <a:xfrm>
+            <a:off x="2402847" y="1902956"/>
+            <a:ext cx="0" cy="2135293"/>
+          </a:xfrm>
+          <a:prstGeom prst="straightConnector1">
+            <a:avLst/>
+          </a:prstGeom>
+          <a:ln>
+            <a:solidFill>
+              <a:schemeClr val="tx1"/>
+            </a:solidFill>
+            <a:tailEnd type="triangle"/>
+          </a:ln>
+        </p:spPr>
+        <p:style>
+          <a:lnRef idx="2">
+            <a:schemeClr val="accent1"/>
+          </a:lnRef>
+          <a:fillRef idx="0">
+            <a:schemeClr val="accent1"/>
+          </a:fillRef>
+          <a:effectRef idx="1">
+            <a:schemeClr val="accent1"/>
+          </a:effectRef>
+          <a:fontRef idx="minor">
+            <a:schemeClr val="tx1"/>
+          </a:fontRef>
+        </p:style>
+      </p:cxnSp>
+      <p:sp>
+        <p:nvSpPr>
+          <p:cNvPr id="83" name="矩形: 圆角 82">
+            <a:extLst>
+              <a:ext uri="{FF2B5EF4-FFF2-40B4-BE49-F238E27FC236}">
+                <a16:creationId xmlns:a16="http://schemas.microsoft.com/office/drawing/2014/main" id="{A05D183E-D314-C3C1-A014-EFB82D40FA8B}"/>
+              </a:ext>
+            </a:extLst>
+          </p:cNvPr>
+          <p:cNvSpPr/>
+          <p:nvPr/>
+        </p:nvSpPr>
+        <p:spPr>
+          <a:xfrm>
+            <a:off x="6684184" y="1243784"/>
+            <a:ext cx="2041120" cy="659173"/>
+          </a:xfrm>
+          <a:prstGeom prst="roundRect">
+            <a:avLst/>
+          </a:prstGeom>
+          <a:noFill/>
+          <a:ln w="19050"/>
+        </p:spPr>
+        <p:style>
+          <a:lnRef idx="2">
+            <a:schemeClr val="accent1">
+              <a:shade val="15000"/>
+            </a:schemeClr>
+          </a:lnRef>
+          <a:fillRef idx="1">
+            <a:schemeClr val="accent1"/>
+          </a:fillRef>
+          <a:effectRef idx="0">
+            <a:schemeClr val="accent1"/>
+          </a:effectRef>
+          <a:fontRef idx="minor">
+            <a:schemeClr val="lt1"/>
+          </a:fontRef>
+        </p:style>
+        <p:txBody>
+          <a:bodyPr rtlCol="0" anchor="ctr"/>
+          <a:lstStyle/>
+          <a:p>
+            <a:pPr algn="ctr"/>
+            <a:r>
+              <a:rPr lang="zh-CN" altLang="en-US" dirty="0">
+                <a:solidFill>
+                  <a:schemeClr val="tx1"/>
+                </a:solidFill>
+              </a:rPr>
+              <a:t>强化学习损失</a:t>
+            </a:r>
+          </a:p>
+        </p:txBody>
+      </p:sp>
+      <p:cxnSp>
+        <p:nvCxnSpPr>
+          <p:cNvPr id="85" name="直接箭头连接符 84">
+            <a:extLst>
+              <a:ext uri="{FF2B5EF4-FFF2-40B4-BE49-F238E27FC236}">
+                <a16:creationId xmlns:a16="http://schemas.microsoft.com/office/drawing/2014/main" id="{9BA616F1-91CC-90A5-D520-E87ECE003807}"/>
+              </a:ext>
+            </a:extLst>
+          </p:cNvPr>
+          <p:cNvCxnSpPr>
+            <a:cxnSpLocks/>
+          </p:cNvCxnSpPr>
+          <p:nvPr/>
+        </p:nvCxnSpPr>
+        <p:spPr>
+          <a:xfrm>
+            <a:off x="6882004" y="2798605"/>
+            <a:ext cx="417956" cy="0"/>
+          </a:xfrm>
+          <a:prstGeom prst="straightConnector1">
+            <a:avLst/>
+          </a:prstGeom>
+          <a:ln>
+            <a:solidFill>
+              <a:schemeClr val="tx1"/>
+            </a:solidFill>
+            <a:tailEnd type="triangle"/>
+          </a:ln>
+        </p:spPr>
+        <p:style>
+          <a:lnRef idx="2">
+            <a:schemeClr val="accent1"/>
+          </a:lnRef>
+          <a:fillRef idx="0">
+            <a:schemeClr val="accent1"/>
+          </a:fillRef>
+          <a:effectRef idx="1">
+            <a:schemeClr val="accent1"/>
+          </a:effectRef>
+          <a:fontRef idx="minor">
+            <a:schemeClr val="tx1"/>
+          </a:fontRef>
+        </p:style>
+      </p:cxnSp>
+      <p:sp>
+        <p:nvSpPr>
+          <p:cNvPr id="86" name="文本框 85">
+            <a:extLst>
+              <a:ext uri="{FF2B5EF4-FFF2-40B4-BE49-F238E27FC236}">
+                <a16:creationId xmlns:a16="http://schemas.microsoft.com/office/drawing/2014/main" id="{56DBE829-C332-F499-1E36-64E146966B3A}"/>
+              </a:ext>
+            </a:extLst>
+          </p:cNvPr>
+          <p:cNvSpPr txBox="1"/>
+          <p:nvPr/>
+        </p:nvSpPr>
+        <p:spPr>
+          <a:xfrm>
+            <a:off x="7252422" y="2636168"/>
+            <a:ext cx="904644" cy="307777"/>
+          </a:xfrm>
+          <a:prstGeom prst="rect">
+            <a:avLst/>
+          </a:prstGeom>
+          <a:noFill/>
+        </p:spPr>
+        <p:txBody>
+          <a:bodyPr wrap="square" rtlCol="0">
+            <a:spAutoFit/>
+          </a:bodyPr>
+          <a:lstStyle/>
+          <a:p>
+            <a:r>
+              <a:rPr lang="zh-CN" altLang="en-US" sz="1400" dirty="0"/>
+              <a:t>电机指令</a:t>
+            </a:r>
+          </a:p>
+        </p:txBody>
+      </p:sp>
+      <p:sp>
+        <p:nvSpPr>
+          <p:cNvPr id="87" name="文本框 86">
+            <a:extLst>
+              <a:ext uri="{FF2B5EF4-FFF2-40B4-BE49-F238E27FC236}">
+                <a16:creationId xmlns:a16="http://schemas.microsoft.com/office/drawing/2014/main" id="{B6B94AC6-6E8F-C7F1-AC6B-9A0C7ABE75CA}"/>
+              </a:ext>
+            </a:extLst>
+          </p:cNvPr>
+          <p:cNvSpPr txBox="1"/>
+          <p:nvPr/>
+        </p:nvSpPr>
+        <p:spPr>
+          <a:xfrm>
+            <a:off x="5948671" y="1184444"/>
+            <a:ext cx="838039" cy="461665"/>
+          </a:xfrm>
+          <a:prstGeom prst="rect">
+            <a:avLst/>
+          </a:prstGeom>
+          <a:noFill/>
+        </p:spPr>
+        <p:txBody>
+          <a:bodyPr wrap="square" rtlCol="0">
+            <a:spAutoFit/>
+          </a:bodyPr>
+          <a:lstStyle/>
+          <a:p>
+            <a:pPr algn="ctr"/>
+            <a:r>
+              <a:rPr lang="zh-CN" altLang="en-US" sz="1200" dirty="0"/>
+              <a:t>状态动作价值</a:t>
+            </a:r>
+          </a:p>
+        </p:txBody>
+      </p:sp>
+      <p:cxnSp>
+        <p:nvCxnSpPr>
+          <p:cNvPr id="96" name="直接箭头连接符 95">
+            <a:extLst>
+              <a:ext uri="{FF2B5EF4-FFF2-40B4-BE49-F238E27FC236}">
+                <a16:creationId xmlns:a16="http://schemas.microsoft.com/office/drawing/2014/main" id="{73D5968E-AC66-40A5-C841-569366457761}"/>
+              </a:ext>
+            </a:extLst>
+          </p:cNvPr>
+          <p:cNvCxnSpPr>
+            <a:cxnSpLocks/>
+            <a:stCxn id="86" idx="0"/>
+            <a:endCxn id="83" idx="2"/>
+          </p:cNvCxnSpPr>
+          <p:nvPr/>
+        </p:nvCxnSpPr>
+        <p:spPr>
+          <a:xfrm flipV="1">
+            <a:off x="7704744" y="1902957"/>
+            <a:ext cx="0" cy="733211"/>
+          </a:xfrm>
+          <a:prstGeom prst="straightConnector1">
+            <a:avLst/>
+          </a:prstGeom>
+          <a:ln>
+            <a:solidFill>
+              <a:schemeClr val="tx1"/>
+            </a:solidFill>
+            <a:tailEnd type="triangle"/>
+          </a:ln>
+        </p:spPr>
+        <p:style>
+          <a:lnRef idx="2">
+            <a:schemeClr val="accent1"/>
+          </a:lnRef>
+          <a:fillRef idx="0">
+            <a:schemeClr val="accent1"/>
+          </a:fillRef>
+          <a:effectRef idx="1">
+            <a:schemeClr val="accent1"/>
+          </a:effectRef>
+          <a:fontRef idx="minor">
+            <a:schemeClr val="tx1"/>
+          </a:fontRef>
+        </p:style>
+      </p:cxnSp>
+      <p:cxnSp>
+        <p:nvCxnSpPr>
+          <p:cNvPr id="97" name="直接箭头连接符 96">
+            <a:extLst>
+              <a:ext uri="{FF2B5EF4-FFF2-40B4-BE49-F238E27FC236}">
+                <a16:creationId xmlns:a16="http://schemas.microsoft.com/office/drawing/2014/main" id="{B2593405-A989-797C-19FD-205AC837EB29}"/>
+              </a:ext>
+            </a:extLst>
+          </p:cNvPr>
+          <p:cNvCxnSpPr>
+            <a:cxnSpLocks/>
+            <a:stCxn id="70" idx="3"/>
+            <a:endCxn id="98" idx="1"/>
+          </p:cNvCxnSpPr>
+          <p:nvPr/>
+        </p:nvCxnSpPr>
+        <p:spPr>
+          <a:xfrm>
+            <a:off x="3149763" y="4400199"/>
+            <a:ext cx="919676" cy="1"/>
+          </a:xfrm>
+          <a:prstGeom prst="straightConnector1">
+            <a:avLst/>
+          </a:prstGeom>
+          <a:ln>
+            <a:solidFill>
+              <a:schemeClr val="tx1"/>
+            </a:solidFill>
+            <a:tailEnd type="triangle"/>
+          </a:ln>
+        </p:spPr>
+        <p:style>
+          <a:lnRef idx="2">
+            <a:schemeClr val="accent1"/>
+          </a:lnRef>
+          <a:fillRef idx="0">
+            <a:schemeClr val="accent1"/>
+          </a:fillRef>
+          <a:effectRef idx="1">
+            <a:schemeClr val="accent1"/>
+          </a:effectRef>
+          <a:fontRef idx="minor">
+            <a:schemeClr val="tx1"/>
+          </a:fontRef>
+        </p:style>
+      </p:cxnSp>
+      <p:sp>
+        <p:nvSpPr>
+          <p:cNvPr id="98" name="文本框 97">
+            <a:extLst>
+              <a:ext uri="{FF2B5EF4-FFF2-40B4-BE49-F238E27FC236}">
+                <a16:creationId xmlns:a16="http://schemas.microsoft.com/office/drawing/2014/main" id="{8C1DE808-B11E-3F43-F6D2-7B8504219BC5}"/>
+              </a:ext>
+            </a:extLst>
+          </p:cNvPr>
+          <p:cNvSpPr txBox="1"/>
+          <p:nvPr/>
+        </p:nvSpPr>
+        <p:spPr>
+          <a:xfrm>
+            <a:off x="4069439" y="4246311"/>
+            <a:ext cx="1457772" cy="307777"/>
+          </a:xfrm>
+          <a:prstGeom prst="rect">
+            <a:avLst/>
+          </a:prstGeom>
+          <a:noFill/>
+        </p:spPr>
+        <p:txBody>
+          <a:bodyPr wrap="square" rtlCol="0">
+            <a:spAutoFit/>
+          </a:bodyPr>
+          <a:lstStyle/>
+          <a:p>
+            <a:r>
+              <a:rPr lang="zh-CN" altLang="en-US" sz="1400" dirty="0"/>
+              <a:t>专家电机指令</a:t>
+            </a:r>
+          </a:p>
+        </p:txBody>
+      </p:sp>
+      <p:sp>
+        <p:nvSpPr>
+          <p:cNvPr id="101" name="矩形: 圆角 100">
+            <a:extLst>
+              <a:ext uri="{FF2B5EF4-FFF2-40B4-BE49-F238E27FC236}">
+                <a16:creationId xmlns:a16="http://schemas.microsoft.com/office/drawing/2014/main" id="{445F99F0-7880-8303-5D68-995BDA30F9A0}"/>
+              </a:ext>
+            </a:extLst>
+          </p:cNvPr>
+          <p:cNvSpPr/>
+          <p:nvPr/>
+        </p:nvSpPr>
+        <p:spPr>
+          <a:xfrm>
+            <a:off x="6684184" y="4100632"/>
+            <a:ext cx="2041121" cy="599134"/>
+          </a:xfrm>
+          <a:prstGeom prst="roundRect">
+            <a:avLst/>
+          </a:prstGeom>
+          <a:noFill/>
+          <a:ln w="19050"/>
+        </p:spPr>
+        <p:style>
+          <a:lnRef idx="2">
+            <a:schemeClr val="accent1">
+              <a:shade val="15000"/>
+            </a:schemeClr>
+          </a:lnRef>
+          <a:fillRef idx="1">
+            <a:schemeClr val="accent1"/>
+          </a:fillRef>
+          <a:effectRef idx="0">
+            <a:schemeClr val="accent1"/>
+          </a:effectRef>
+          <a:fontRef idx="minor">
+            <a:schemeClr val="lt1"/>
+          </a:fontRef>
+        </p:style>
+        <p:txBody>
+          <a:bodyPr rtlCol="0" anchor="ctr"/>
+          <a:lstStyle/>
+          <a:p>
+            <a:pPr algn="ctr"/>
+            <a:r>
+              <a:rPr lang="zh-CN" altLang="en-US" dirty="0">
+                <a:solidFill>
+                  <a:schemeClr val="tx1"/>
+                </a:solidFill>
+              </a:rPr>
+              <a:t>基于物理的</a:t>
+            </a:r>
+            <a:endParaRPr lang="en-US" altLang="zh-CN" dirty="0">
+              <a:solidFill>
+                <a:schemeClr val="tx1"/>
+              </a:solidFill>
+            </a:endParaRPr>
+          </a:p>
+          <a:p>
+            <a:pPr algn="ctr"/>
+            <a:r>
+              <a:rPr lang="zh-CN" altLang="en-US" dirty="0">
+                <a:solidFill>
+                  <a:schemeClr val="tx1"/>
+                </a:solidFill>
+              </a:rPr>
+              <a:t>模仿学习损失</a:t>
+            </a:r>
+          </a:p>
+        </p:txBody>
+      </p:sp>
+      <p:cxnSp>
+        <p:nvCxnSpPr>
+          <p:cNvPr id="105" name="直接箭头连接符 104">
+            <a:extLst>
+              <a:ext uri="{FF2B5EF4-FFF2-40B4-BE49-F238E27FC236}">
+                <a16:creationId xmlns:a16="http://schemas.microsoft.com/office/drawing/2014/main" id="{B6DBD47A-2AF1-E4CD-E72E-5487A2E22927}"/>
+              </a:ext>
+            </a:extLst>
+          </p:cNvPr>
+          <p:cNvCxnSpPr>
+            <a:cxnSpLocks/>
+            <a:endCxn id="101" idx="1"/>
+          </p:cNvCxnSpPr>
+          <p:nvPr/>
+        </p:nvCxnSpPr>
+        <p:spPr>
+          <a:xfrm>
+            <a:off x="5331869" y="4400199"/>
+            <a:ext cx="1352315" cy="0"/>
+          </a:xfrm>
+          <a:prstGeom prst="straightConnector1">
+            <a:avLst/>
+          </a:prstGeom>
+          <a:ln>
+            <a:solidFill>
+              <a:schemeClr val="tx1"/>
+            </a:solidFill>
+            <a:tailEnd type="triangle"/>
+          </a:ln>
+        </p:spPr>
+        <p:style>
+          <a:lnRef idx="2">
+            <a:schemeClr val="accent1"/>
+          </a:lnRef>
+          <a:fillRef idx="0">
+            <a:schemeClr val="accent1"/>
+          </a:fillRef>
+          <a:effectRef idx="1">
+            <a:schemeClr val="accent1"/>
+          </a:effectRef>
+          <a:fontRef idx="minor">
+            <a:schemeClr val="tx1"/>
+          </a:fontRef>
+        </p:style>
+      </p:cxnSp>
+      <p:cxnSp>
+        <p:nvCxnSpPr>
+          <p:cNvPr id="106" name="直接箭头连接符 105">
+            <a:extLst>
+              <a:ext uri="{FF2B5EF4-FFF2-40B4-BE49-F238E27FC236}">
+                <a16:creationId xmlns:a16="http://schemas.microsoft.com/office/drawing/2014/main" id="{91C5D24A-1628-8715-18DD-B2C2883D31B5}"/>
+              </a:ext>
+            </a:extLst>
+          </p:cNvPr>
+          <p:cNvCxnSpPr>
+            <a:cxnSpLocks/>
+            <a:stCxn id="86" idx="2"/>
+            <a:endCxn id="101" idx="0"/>
+          </p:cNvCxnSpPr>
+          <p:nvPr/>
+        </p:nvCxnSpPr>
+        <p:spPr>
+          <a:xfrm>
+            <a:off x="7704744" y="2943945"/>
+            <a:ext cx="1" cy="1156687"/>
+          </a:xfrm>
+          <a:prstGeom prst="straightConnector1">
+            <a:avLst/>
+          </a:prstGeom>
+          <a:ln>
+            <a:solidFill>
+              <a:schemeClr val="tx1"/>
+            </a:solidFill>
+            <a:tailEnd type="triangle"/>
+          </a:ln>
+        </p:spPr>
+        <p:style>
+          <a:lnRef idx="2">
+            <a:schemeClr val="accent1"/>
+          </a:lnRef>
+          <a:fillRef idx="0">
+            <a:schemeClr val="accent1"/>
+          </a:fillRef>
+          <a:effectRef idx="1">
+            <a:schemeClr val="accent1"/>
+          </a:effectRef>
+          <a:fontRef idx="minor">
+            <a:schemeClr val="tx1"/>
+          </a:fontRef>
+        </p:style>
+      </p:cxnSp>
+      <p:sp>
+        <p:nvSpPr>
+          <p:cNvPr id="122" name="矩形: 圆角 121">
+            <a:extLst>
+              <a:ext uri="{FF2B5EF4-FFF2-40B4-BE49-F238E27FC236}">
+                <a16:creationId xmlns:a16="http://schemas.microsoft.com/office/drawing/2014/main" id="{E9595928-DCF1-25D5-D57F-D0D329B84685}"/>
+              </a:ext>
+            </a:extLst>
+          </p:cNvPr>
+          <p:cNvSpPr/>
+          <p:nvPr/>
+        </p:nvSpPr>
+        <p:spPr>
+          <a:xfrm>
+            <a:off x="8390719" y="2488661"/>
+            <a:ext cx="1863045" cy="599134"/>
+          </a:xfrm>
+          <a:prstGeom prst="roundRect">
+            <a:avLst/>
+          </a:prstGeom>
+          <a:noFill/>
+          <a:ln w="19050"/>
+        </p:spPr>
+        <p:style>
+          <a:lnRef idx="2">
+            <a:schemeClr val="accent1">
+              <a:shade val="15000"/>
+            </a:schemeClr>
+          </a:lnRef>
+          <a:fillRef idx="1">
+            <a:schemeClr val="accent1"/>
+          </a:fillRef>
+          <a:effectRef idx="0">
+            <a:schemeClr val="accent1"/>
+          </a:effectRef>
+          <a:fontRef idx="minor">
+            <a:schemeClr val="lt1"/>
+          </a:fontRef>
+        </p:style>
+        <p:txBody>
+          <a:bodyPr rtlCol="0" anchor="ctr"/>
+          <a:lstStyle/>
+          <a:p>
+            <a:pPr algn="ctr"/>
+            <a:r>
+              <a:rPr lang="zh-CN" altLang="en-US" dirty="0">
+                <a:solidFill>
+                  <a:schemeClr val="tx1"/>
+                </a:solidFill>
+              </a:rPr>
+              <a:t>混合学习</a:t>
+            </a:r>
+          </a:p>
+        </p:txBody>
+      </p:sp>
+      <p:cxnSp>
+        <p:nvCxnSpPr>
+          <p:cNvPr id="124" name="连接符: 肘形 123">
+            <a:extLst>
+              <a:ext uri="{FF2B5EF4-FFF2-40B4-BE49-F238E27FC236}">
+                <a16:creationId xmlns:a16="http://schemas.microsoft.com/office/drawing/2014/main" id="{05C07EC5-C8E4-A992-AC6B-3776DFD7A891}"/>
+              </a:ext>
+            </a:extLst>
+          </p:cNvPr>
+          <p:cNvCxnSpPr>
+            <a:cxnSpLocks/>
+            <a:stCxn id="83" idx="3"/>
+            <a:endCxn id="122" idx="0"/>
+          </p:cNvCxnSpPr>
+          <p:nvPr/>
+        </p:nvCxnSpPr>
+        <p:spPr>
+          <a:xfrm>
+            <a:off x="8725304" y="1573371"/>
+            <a:ext cx="596938" cy="915290"/>
+          </a:xfrm>
+          <a:prstGeom prst="bentConnector2">
+            <a:avLst/>
+          </a:prstGeom>
+          <a:ln>
+            <a:tailEnd type="triangle"/>
+          </a:ln>
+        </p:spPr>
+        <p:style>
+          <a:lnRef idx="2">
+            <a:schemeClr val="dk1"/>
+          </a:lnRef>
+          <a:fillRef idx="0">
+            <a:schemeClr val="dk1"/>
+          </a:fillRef>
+          <a:effectRef idx="1">
+            <a:schemeClr val="dk1"/>
+          </a:effectRef>
+          <a:fontRef idx="minor">
+            <a:schemeClr val="tx1"/>
+          </a:fontRef>
+        </p:style>
+      </p:cxnSp>
+      <p:cxnSp>
+        <p:nvCxnSpPr>
+          <p:cNvPr id="126" name="连接符: 肘形 125">
+            <a:extLst>
+              <a:ext uri="{FF2B5EF4-FFF2-40B4-BE49-F238E27FC236}">
+                <a16:creationId xmlns:a16="http://schemas.microsoft.com/office/drawing/2014/main" id="{BE5181EB-20C0-6F32-C96B-20B9252A61A4}"/>
+              </a:ext>
+            </a:extLst>
+          </p:cNvPr>
+          <p:cNvCxnSpPr>
+            <a:cxnSpLocks/>
+            <a:stCxn id="101" idx="3"/>
+            <a:endCxn id="122" idx="2"/>
+          </p:cNvCxnSpPr>
+          <p:nvPr/>
+        </p:nvCxnSpPr>
+        <p:spPr>
+          <a:xfrm flipV="1">
+            <a:off x="8725305" y="3087795"/>
+            <a:ext cx="596937" cy="1312404"/>
+          </a:xfrm>
+          <a:prstGeom prst="bentConnector2">
+            <a:avLst/>
+          </a:prstGeom>
+          <a:ln>
+            <a:tailEnd type="triangle"/>
+          </a:ln>
+        </p:spPr>
+        <p:style>
+          <a:lnRef idx="2">
+            <a:schemeClr val="dk1"/>
+          </a:lnRef>
+          <a:fillRef idx="0">
+            <a:schemeClr val="dk1"/>
+          </a:fillRef>
+          <a:effectRef idx="1">
+            <a:schemeClr val="dk1"/>
+          </a:effectRef>
+          <a:fontRef idx="minor">
+            <a:schemeClr val="tx1"/>
+          </a:fontRef>
+        </p:style>
+      </p:cxnSp>
+      <p:sp>
+        <p:nvSpPr>
+          <p:cNvPr id="133" name="矩形: 圆角 132">
+            <a:extLst>
+              <a:ext uri="{FF2B5EF4-FFF2-40B4-BE49-F238E27FC236}">
+                <a16:creationId xmlns:a16="http://schemas.microsoft.com/office/drawing/2014/main" id="{17E865F2-BF43-7CAA-F9AD-6AAF27026139}"/>
+              </a:ext>
+            </a:extLst>
+          </p:cNvPr>
+          <p:cNvSpPr/>
+          <p:nvPr/>
+        </p:nvSpPr>
+        <p:spPr>
+          <a:xfrm>
+            <a:off x="3968330" y="3566710"/>
+            <a:ext cx="1390006" cy="566821"/>
+          </a:xfrm>
+          <a:prstGeom prst="roundRect">
+            <a:avLst/>
+          </a:prstGeom>
+          <a:noFill/>
+        </p:spPr>
+        <p:style>
+          <a:lnRef idx="2">
+            <a:schemeClr val="accent1">
+              <a:shade val="15000"/>
+            </a:schemeClr>
+          </a:lnRef>
+          <a:fillRef idx="1">
+            <a:schemeClr val="accent1"/>
+          </a:fillRef>
+          <a:effectRef idx="0">
+            <a:schemeClr val="accent1"/>
+          </a:effectRef>
+          <a:fontRef idx="minor">
+            <a:schemeClr val="lt1"/>
+          </a:fontRef>
+        </p:style>
+        <p:txBody>
+          <a:bodyPr rtlCol="0" anchor="ctr"/>
+          <a:lstStyle/>
+          <a:p>
+            <a:pPr algn="ctr"/>
+            <a:r>
+              <a:rPr lang="zh-CN" altLang="en-US" dirty="0">
+                <a:solidFill>
+                  <a:schemeClr val="tx1"/>
+                </a:solidFill>
+              </a:rPr>
+              <a:t>多任务监督</a:t>
+            </a:r>
+          </a:p>
+        </p:txBody>
+      </p:sp>
+      <p:cxnSp>
+        <p:nvCxnSpPr>
+          <p:cNvPr id="137" name="连接符: 肘形 136">
+            <a:extLst>
+              <a:ext uri="{FF2B5EF4-FFF2-40B4-BE49-F238E27FC236}">
+                <a16:creationId xmlns:a16="http://schemas.microsoft.com/office/drawing/2014/main" id="{6BA80EB8-757C-3952-492E-0F7BA8D67C91}"/>
+              </a:ext>
+            </a:extLst>
+          </p:cNvPr>
+          <p:cNvCxnSpPr>
+            <a:cxnSpLocks/>
+            <a:stCxn id="23" idx="2"/>
+            <a:endCxn id="133" idx="1"/>
+          </p:cNvCxnSpPr>
+          <p:nvPr/>
+        </p:nvCxnSpPr>
+        <p:spPr>
+          <a:xfrm rot="16200000" flipH="1">
+            <a:off x="2864476" y="2746267"/>
+            <a:ext cx="1048526" cy="1159181"/>
+          </a:xfrm>
+          <a:prstGeom prst="bentConnector2">
+            <a:avLst/>
+          </a:prstGeom>
+          <a:ln>
+            <a:solidFill>
+              <a:schemeClr val="tx1"/>
+            </a:solidFill>
+            <a:tailEnd type="triangle"/>
+          </a:ln>
+        </p:spPr>
+        <p:style>
+          <a:lnRef idx="2">
+            <a:schemeClr val="accent1"/>
+          </a:lnRef>
+          <a:fillRef idx="0">
+            <a:schemeClr val="accent1"/>
+          </a:fillRef>
+          <a:effectRef idx="1">
+            <a:schemeClr val="accent1"/>
+          </a:effectRef>
+          <a:fontRef idx="minor">
+            <a:schemeClr val="tx1"/>
+          </a:fontRef>
+        </p:style>
+      </p:cxnSp>
+      <p:sp>
+        <p:nvSpPr>
+          <p:cNvPr id="139" name="文本框 138">
+            <a:extLst>
+              <a:ext uri="{FF2B5EF4-FFF2-40B4-BE49-F238E27FC236}">
+                <a16:creationId xmlns:a16="http://schemas.microsoft.com/office/drawing/2014/main" id="{E5EEA7BF-DCB8-905E-FA6F-25309BB17903}"/>
+              </a:ext>
+            </a:extLst>
+          </p:cNvPr>
+          <p:cNvSpPr txBox="1"/>
+          <p:nvPr/>
+        </p:nvSpPr>
+        <p:spPr>
+          <a:xfrm>
+            <a:off x="2778066" y="3545807"/>
+            <a:ext cx="881941" cy="276999"/>
+          </a:xfrm>
+          <a:prstGeom prst="rect">
+            <a:avLst/>
+          </a:prstGeom>
+          <a:noFill/>
+        </p:spPr>
+        <p:txBody>
+          <a:bodyPr wrap="square" rtlCol="0">
+            <a:spAutoFit/>
+          </a:bodyPr>
+          <a:lstStyle/>
+          <a:p>
+            <a:pPr algn="ctr"/>
+            <a:r>
+              <a:rPr lang="zh-CN" altLang="en-US" sz="1200" dirty="0"/>
+              <a:t>标签信息</a:t>
+            </a:r>
+          </a:p>
+        </p:txBody>
+      </p:sp>
+      <p:cxnSp>
+        <p:nvCxnSpPr>
+          <p:cNvPr id="143" name="连接符: 肘形 142">
+            <a:extLst>
+              <a:ext uri="{FF2B5EF4-FFF2-40B4-BE49-F238E27FC236}">
+                <a16:creationId xmlns:a16="http://schemas.microsoft.com/office/drawing/2014/main" id="{3A65F4E7-D379-3113-C760-5A454B62A2EB}"/>
+              </a:ext>
+            </a:extLst>
+          </p:cNvPr>
+          <p:cNvCxnSpPr>
+            <a:cxnSpLocks/>
+          </p:cNvCxnSpPr>
+          <p:nvPr/>
+        </p:nvCxnSpPr>
+        <p:spPr>
+          <a:xfrm rot="16200000" flipH="1">
+            <a:off x="5059588" y="3397010"/>
+            <a:ext cx="336581" cy="1"/>
+          </a:xfrm>
+          <a:prstGeom prst="bentConnector3">
+            <a:avLst>
+              <a:gd name="adj1" fmla="val 50000"/>
+            </a:avLst>
+          </a:prstGeom>
+          <a:ln>
+            <a:solidFill>
+              <a:schemeClr val="tx1"/>
+            </a:solidFill>
+            <a:tailEnd type="triangle"/>
+          </a:ln>
+        </p:spPr>
+        <p:style>
+          <a:lnRef idx="2">
+            <a:schemeClr val="accent1"/>
+          </a:lnRef>
+          <a:fillRef idx="0">
+            <a:schemeClr val="accent1"/>
+          </a:fillRef>
+          <a:effectRef idx="1">
+            <a:schemeClr val="accent1"/>
+          </a:effectRef>
+          <a:fontRef idx="minor">
+            <a:schemeClr val="tx1"/>
+          </a:fontRef>
+        </p:style>
+      </p:cxnSp>
+      <p:sp>
+        <p:nvSpPr>
+          <p:cNvPr id="37" name="文本框 36">
+            <a:extLst>
+              <a:ext uri="{FF2B5EF4-FFF2-40B4-BE49-F238E27FC236}">
+                <a16:creationId xmlns:a16="http://schemas.microsoft.com/office/drawing/2014/main" id="{7452332F-ECF9-D1CE-53E1-B12223D33ABD}"/>
+              </a:ext>
+            </a:extLst>
+          </p:cNvPr>
+          <p:cNvSpPr txBox="1"/>
+          <p:nvPr/>
+        </p:nvSpPr>
+        <p:spPr>
+          <a:xfrm>
+            <a:off x="1312584" y="3024572"/>
+            <a:ext cx="1244038" cy="276999"/>
+          </a:xfrm>
+          <a:prstGeom prst="rect">
+            <a:avLst/>
+          </a:prstGeom>
+          <a:noFill/>
+        </p:spPr>
+        <p:txBody>
+          <a:bodyPr wrap="square" rtlCol="0">
+            <a:spAutoFit/>
+          </a:bodyPr>
+          <a:lstStyle/>
+          <a:p>
+            <a:pPr algn="ctr"/>
+            <a:r>
+              <a:rPr lang="zh-CN" altLang="en-US" sz="1200" dirty="0"/>
+              <a:t>物理状态信息</a:t>
+            </a:r>
+          </a:p>
+        </p:txBody>
+      </p:sp>
+      <p:cxnSp>
+        <p:nvCxnSpPr>
+          <p:cNvPr id="52" name="直接箭头连接符 51">
+            <a:extLst>
+              <a:ext uri="{FF2B5EF4-FFF2-40B4-BE49-F238E27FC236}">
+                <a16:creationId xmlns:a16="http://schemas.microsoft.com/office/drawing/2014/main" id="{F0511854-33D6-302A-3B3B-1523E4172642}"/>
+              </a:ext>
+            </a:extLst>
+          </p:cNvPr>
+          <p:cNvCxnSpPr>
+            <a:cxnSpLocks/>
+          </p:cNvCxnSpPr>
+          <p:nvPr/>
+        </p:nvCxnSpPr>
+        <p:spPr>
+          <a:xfrm>
+            <a:off x="2411995" y="2798605"/>
+            <a:ext cx="1305789" cy="0"/>
+          </a:xfrm>
+          <a:prstGeom prst="straightConnector1">
+            <a:avLst/>
+          </a:prstGeom>
+          <a:ln>
+            <a:solidFill>
+              <a:schemeClr val="tx1"/>
+            </a:solidFill>
+            <a:tailEnd type="triangle"/>
+          </a:ln>
+        </p:spPr>
+        <p:style>
+          <a:lnRef idx="2">
+            <a:schemeClr val="accent1"/>
+          </a:lnRef>
+          <a:fillRef idx="0">
+            <a:schemeClr val="accent1"/>
+          </a:fillRef>
+          <a:effectRef idx="1">
+            <a:schemeClr val="accent1"/>
+          </a:effectRef>
+          <a:fontRef idx="minor">
+            <a:schemeClr val="tx1"/>
+          </a:fontRef>
+        </p:style>
+      </p:cxnSp>
+      <p:cxnSp>
+        <p:nvCxnSpPr>
+          <p:cNvPr id="75" name="连接符: 肘形 74">
+            <a:extLst>
+              <a:ext uri="{FF2B5EF4-FFF2-40B4-BE49-F238E27FC236}">
+                <a16:creationId xmlns:a16="http://schemas.microsoft.com/office/drawing/2014/main" id="{E549EA92-838A-871E-E620-BA06151EA119}"/>
+              </a:ext>
+            </a:extLst>
+          </p:cNvPr>
+          <p:cNvCxnSpPr>
+            <a:cxnSpLocks/>
+          </p:cNvCxnSpPr>
+          <p:nvPr/>
+        </p:nvCxnSpPr>
+        <p:spPr>
+          <a:xfrm rot="16200000" flipH="1">
+            <a:off x="4007727" y="3395836"/>
+            <a:ext cx="336581" cy="1"/>
+          </a:xfrm>
+          <a:prstGeom prst="bentConnector3">
+            <a:avLst>
+              <a:gd name="adj1" fmla="val 50000"/>
+            </a:avLst>
+          </a:prstGeom>
+          <a:ln>
+            <a:solidFill>
+              <a:schemeClr val="tx1"/>
+            </a:solidFill>
+            <a:tailEnd type="triangle"/>
+          </a:ln>
+        </p:spPr>
+        <p:style>
+          <a:lnRef idx="2">
+            <a:schemeClr val="accent1"/>
+          </a:lnRef>
+          <a:fillRef idx="0">
+            <a:schemeClr val="accent1"/>
+          </a:fillRef>
+          <a:effectRef idx="1">
+            <a:schemeClr val="accent1"/>
+          </a:effectRef>
+          <a:fontRef idx="minor">
+            <a:schemeClr val="tx1"/>
+          </a:fontRef>
+        </p:style>
+      </p:cxnSp>
+      <p:cxnSp>
+        <p:nvCxnSpPr>
+          <p:cNvPr id="102" name="直接箭头连接符 101">
+            <a:extLst>
+              <a:ext uri="{FF2B5EF4-FFF2-40B4-BE49-F238E27FC236}">
+                <a16:creationId xmlns:a16="http://schemas.microsoft.com/office/drawing/2014/main" id="{78002BAE-4641-6868-D187-6BA7AF72AFCE}"/>
+              </a:ext>
+            </a:extLst>
+          </p:cNvPr>
+          <p:cNvCxnSpPr>
+            <a:cxnSpLocks/>
+          </p:cNvCxnSpPr>
+          <p:nvPr/>
+        </p:nvCxnSpPr>
+        <p:spPr>
+          <a:xfrm>
+            <a:off x="6006040" y="1577877"/>
+            <a:ext cx="678144" cy="0"/>
+          </a:xfrm>
+          <a:prstGeom prst="straightConnector1">
+            <a:avLst/>
+          </a:prstGeom>
+          <a:ln>
+            <a:solidFill>
+              <a:schemeClr val="tx1"/>
+            </a:solidFill>
+            <a:tailEnd type="triangle"/>
+          </a:ln>
+        </p:spPr>
+        <p:style>
+          <a:lnRef idx="2">
+            <a:schemeClr val="accent1"/>
+          </a:lnRef>
+          <a:fillRef idx="0">
+            <a:schemeClr val="accent1"/>
+          </a:fillRef>
+          <a:effectRef idx="1">
+            <a:schemeClr val="accent1"/>
+          </a:effectRef>
+          <a:fontRef idx="minor">
+            <a:schemeClr val="tx1"/>
+          </a:fontRef>
+        </p:style>
+      </p:cxnSp>
+    </p:spTree>
+    <p:extLst>
+      <p:ext uri="{BB962C8B-B14F-4D97-AF65-F5344CB8AC3E}">
+        <p14:creationId xmlns:p14="http://schemas.microsoft.com/office/powerpoint/2010/main" val="1417030791"/>
       </p:ext>
     </p:extLst>
   </p:cSld>

</xml_diff>